<commit_message>
pitch: speaking script (Flutura problem, Devlete narrates demo, Tringa after demo, Flutura close) + Q&A owners; deck notes updated
Co-Authored-By: Claude Opus 5.5 <noreply@anthropic.com>
</commit_message>
<xml_diff>
--- a/pitch/Hi5_AI_Team_Leader.pptx
+++ b/pitch/Hi5_AI_Team_Leader.pptx
@@ -284,12 +284,7 @@
           <a:lstStyle/>
           <a:p>
             <a:r>
-              <a:t>FLUTURA (0:00–0:15)</a:t>
-            </a:r>
-          </a:p>
-          <a:p>
-            <a:r>
-              <a:t>"We are Hi5. We built an AI Team Leader for businesses whose work happens at a place and a time. Our real user is Magic Events, an events business in Kosovo, and the owners gave us written permission to use their story."</a:t>
+              <a:t>FLUTURA (0:00) — "Good afternoon. We're Hi5, and we built an AI Team Leader."</a:t>
             </a:r>
           </a:p>
         </p:txBody>
@@ -375,27 +370,12 @@
           <a:lstStyle/>
           <a:p>
             <a:r>
-              <a:t>FLUTURA (0:15–0:50)</a:t>
-            </a:r>
-          </a:p>
-          <a:p>
-            <a:r>
-              <a:t>"When a client says yes, the work only starts: people, skills, the van, equipment, time and place all have to line up. Today it runs on WhatsApp, Viber and phone calls.</a:t>
-            </a:r>
-          </a:p>
-          <a:p>
-            <a:r>
-              <a:t>In one difficult case, coordination took about four hours. Once, a worker was moved to fix one event and the other event started an hour late. And workers sometimes drop out only thirty minutes before leaving.</a:t>
-            </a:r>
-          </a:p>
-          <a:p>
-            <a:r>
-              <a:t>The question isn't 'is someone free?'. It's 'can the whole company deliver this without breaking something else?'"</a:t>
-            </a:r>
-          </a:p>
-          <a:p>
-            <a:r>
-              <a:t>→ GENTI: LIVE DEMO (2:30) — no slide</a:t>
+              <a:t>FLUTURA (0:05–1:00) — Magic Events (Rinor &amp; Elmonda Hyseni, permission). When a client says yes, the work only starts: people, skills, van, equipment, time, place. Today: WhatsApp, Viber, calls. ~4 hours in a difficult case · the other event an hour late · a worker drops out 30 min before. "The question isn't 'is someone free?'. It's 'can we deliver this job without breaking something else?' Let us show you."</a:t>
+            </a:r>
+          </a:p>
+          <a:p>
+            <a:r>
+              <a:t>→ DEMO 1:00–3:15: GENTI drives, DEVLETE narrates (pitch/SCRIPT.md), ERZA + FLUTURA on phones.</a:t>
             </a:r>
           </a:p>
         </p:txBody>
@@ -481,42 +461,12 @@
           <a:lstStyle/>
           <a:p>
             <a:r>
-              <a:t>GENTI (3:20–4:10) — after the demo</a:t>
-            </a:r>
-          </a:p>
-          <a:p>
-            <a:r>
-              <a:t>"What you saw: AI plans, code checks, a human approves. The model reads the leader's message and writes the tasks, but every rule (skills, travel time, vans, equipment, working hours) is checked in code, so nobody can talk it out of a rule, not even the manager. The agent can't approve and can't book anyone without ACCEPT.</a:t>
-            </a:r>
-          </a:p>
-          <a:p>
-            <a:r>
-              <a:t>Measured in our run: plan in 16 seconds, approval to everyone accepting in 8 seconds, about 3 cents per plan."</a:t>
-            </a:r>
-          </a:p>
-          <a:p>
-            <a:r>
-              <a:t>TRINGA (4:10–5:00)</a:t>
-            </a:r>
-          </a:p>
-          <a:p>
-            <a:r>
-              <a:t>"Today: small teams, with tasks, what to bring, check-in, progress and a report. Next: the same agent as a PM's assistant in larger companies, with reports for each role.</a:t>
-            </a:r>
-          </a:p>
-          <a:p>
-            <a:r>
-              <a:t>Tools like Connecteam, Microsoft Planner, Asana and Jira already help teams. What we show is the full handoff in one flow, from the client's request to the team doing the work.</a:t>
-            </a:r>
-          </a:p>
-          <a:p>
-            <a:r>
-              <a:t>Our next step is a proposed four-Saturday pilot with Magic Events, measuring coordination time and mistakes.</a:t>
-            </a:r>
-          </a:p>
-          <a:p>
-            <a:r>
-              <a:t>Your leader keeps the client. We turn the yes into a plan that holds, and follow it through to the end."</a:t>
+              <a:t>TRINGA (3:15–4:45) — "AI plans. Code checks. A human approves." Measured: plan in 16 s, all confirmed 8 s after approval, ~3 cents per plan. Honest market: Connecteam, Planner, Asana, Jira already help teams; we bring the whole handoff in one flow, in their chat, in Albanian. Today small field teams; next a PM's assistant in larger companies. Next step: proposed four-Saturday pilot with Magic Events.</a:t>
+            </a:r>
+          </a:p>
+          <a:p>
+            <a:r>
+              <a:t>FLUTURA (4:45–5:00) — "Your leader keeps the client. We turn the 'yes' into a plan that holds, and follow it through to the end. Thank you."</a:t>
             </a:r>
           </a:p>
         </p:txBody>

</xml_diff>

<commit_message>
pitch: Flutura + Devlete only; general problem first, Magic Events as the example; Devlete narrates demo + numbers; Flutura why/next/close
Co-Authored-By: Claude Opus 5.5 <noreply@anthropic.com>
</commit_message>
<xml_diff>
--- a/pitch/Hi5_AI_Team_Leader.pptx
+++ b/pitch/Hi5_AI_Team_Leader.pptx
@@ -284,7 +284,7 @@
           <a:lstStyle/>
           <a:p>
             <a:r>
-              <a:t>FLUTURA (0:00) — "Good afternoon. We're Hi5, and we built an AI Team Leader."</a:t>
+              <a:t>FLUTURA (0:00–0:40) — GENERAL: "Good afternoon, we're Hi5. Think of any business that sells work done by a team in the field: events, cleaning, installation, maintenance, construction. Every time a client says yes, a coordination problem starts: people, vehicles and equipment in the right place at the right time, without clashing with jobs already booked. Today it lives in one person's head and on WhatsApp, and one quick fix often breaks another job."</a:t>
             </a:r>
           </a:p>
         </p:txBody>
@@ -370,12 +370,12 @@
           <a:lstStyle/>
           <a:p>
             <a:r>
-              <a:t>FLUTURA (0:05–1:00) — Magic Events (Rinor &amp; Elmonda Hyseni, permission). When a client says yes, the work only starts: people, skills, van, equipment, time, place. Today: WhatsApp, Viber, calls. ~4 hours in a difficult case · the other event an hour late · a worker drops out 30 min before. "The question isn't 'is someone free?'. It's 'can we deliver this job without breaking something else?' Let us show you."</a:t>
-            </a:r>
-          </a:p>
-          <a:p>
-            <a:r>
-              <a:t>→ DEMO 1:00–3:15: GENTI drives, DEVLETE narrates (pitch/SCRIPT.md), ERZA + FLUTURA on phones.</a:t>
+              <a:t>FLUTURA (0:40–1:15) — EXAMPLE: Magic Events (permission). ~4 hours coordinating in a difficult case · the other event an hour late · workers drop out 30 min before. "The real question isn't 'is someone free?'. It's 'can we deliver this job without breaking something else?' That's why we built an AI Team Leader. Devlete will show you."</a:t>
+            </a:r>
+          </a:p>
+          <a:p>
+            <a:r>
+              <a:t>→ DEMO 1:15–3:30: DEVLETE narrates (pitch/SCRIPT.md), GENTI drives, ERZA + FLUTURA on phones. Devlete ends: "AI plans. Code checks. A human approves. Plan in 16 s, all confirmed 8 s after approval, ~3 cents per plan."</a:t>
             </a:r>
           </a:p>
         </p:txBody>
@@ -461,12 +461,7 @@
           <a:lstStyle/>
           <a:p>
             <a:r>
-              <a:t>TRINGA (3:15–4:45) — "AI plans. Code checks. A human approves." Measured: plan in 16 s, all confirmed 8 s after approval, ~3 cents per plan. Honest market: Connecteam, Planner, Asana, Jira already help teams; we bring the whole handoff in one flow, in their chat, in Albanian. Today small field teams; next a PM's assistant in larger companies. Next step: proposed four-Saturday pilot with Magic Events.</a:t>
-            </a:r>
-          </a:p>
-          <a:p>
-            <a:r>
-              <a:t>FLUTURA (4:45–5:00) — "Your leader keeps the client. We turn the 'yes' into a plan that holds, and follow it through to the end. Thank you."</a:t>
+              <a:t>FLUTURA (3:30–5:00) — Works for any team away from a desk: small business gets a team leader it couldn't hire; bigger companies get an assistant for their PMs, reports for every role. Honest market: Connecteam, Planner, Asana, Jira already help teams; we bring the whole handoff in one flow, in their chat, in Albanian. Next: proposed four-Saturday pilot with Magic Events. CLOSE: "Your leader keeps the client. We turn the 'yes' into a plan that holds, and follow it through to the end. Thank you."</a:t>
             </a:r>
           </a:p>
         </p:txBody>

</xml_diff>

<commit_message>
pitch: only Flutura speaks; Devlete holds Flutura's phone in the demo; Tringa timer/slides
Co-Authored-By: Claude Opus 5.5 <noreply@anthropic.com>
</commit_message>
<xml_diff>
--- a/pitch/Hi5_AI_Team_Leader.pptx
+++ b/pitch/Hi5_AI_Team_Leader.pptx
@@ -370,12 +370,12 @@
           <a:lstStyle/>
           <a:p>
             <a:r>
-              <a:t>FLUTURA (0:40–1:15) — EXAMPLE: Magic Events (permission). ~4 hours coordinating in a difficult case · the other event an hour late · workers drop out 30 min before. "The real question isn't 'is someone free?'. It's 'can we deliver this job without breaking something else?' That's why we built an AI Team Leader. Devlete will show you."</a:t>
-            </a:r>
-          </a:p>
-          <a:p>
-            <a:r>
-              <a:t>→ DEMO 1:15–3:30: DEVLETE narrates (pitch/SCRIPT.md), GENTI drives, ERZA + FLUTURA on phones. Devlete ends: "AI plans. Code checks. A human approves. Plan in 16 s, all confirmed 8 s after approval, ~3 cents per plan."</a:t>
+              <a:t>FLUTURA (0:40–1:15) — EXAMPLE: Magic Events (permission). ~4 hours coordinating in a difficult case · the other event an hour late · workers drop out 30 min before. "The real question isn't 'is someone free?'. It's 'can we deliver this job without breaking something else?' That's why we built an AI Team Leader. Let me show you, live."</a:t>
+            </a:r>
+          </a:p>
+          <a:p>
+            <a:r>
+              <a:t>→ DEMO 1:15–3:30: FLUTURA narrates (pitch/SCRIPT.md), GENTI drives, ERZA + DEVLETE (Flutura's phone) on phones. Flutura ends: "AI plans. Code checks. A human approves. Plan in 16 s, all confirmed 8 s after approval, ~3 cents per plan."</a:t>
             </a:r>
           </a:p>
         </p:txBody>

</xml_diff>

<commit_message>
pitch: Flutura opens, Erza narrates demo, Devlete closes; Genti panel, Tringa holds Erza's phone, Flutura her own phone
Co-Authored-By: Claude Opus 5.5 <noreply@anthropic.com>
</commit_message>
<xml_diff>
--- a/pitch/Hi5_AI_Team_Leader.pptx
+++ b/pitch/Hi5_AI_Team_Leader.pptx
@@ -284,7 +284,7 @@
           <a:lstStyle/>
           <a:p>
             <a:r>
-              <a:t>FLUTURA (0:00–0:40) — GENERAL: "Good afternoon, we're Hi5. Think of any business that sells work done by a team in the field: events, cleaning, installation, maintenance, construction. Every time a client says yes, a coordination problem starts: people, vehicles and equipment in the right place at the right time, without clashing with jobs already booked. Today it lives in one person's head and on WhatsApp, and one quick fix often breaks another job."</a:t>
+              <a:t>FLUTURA (0:00–0:40) — GENERAL: "Good afternoon, we're Hi5. Think of any business that sells work done by a team in the field: events, cleaning, installation, maintenance, construction. Every time a client says yes, a coordination problem starts... Today it lives in one person's head and on WhatsApp, and one quick fix often breaks another job."</a:t>
             </a:r>
           </a:p>
         </p:txBody>
@@ -370,12 +370,12 @@
           <a:lstStyle/>
           <a:p>
             <a:r>
-              <a:t>FLUTURA (0:40–1:15) — EXAMPLE: Magic Events (permission). ~4 hours coordinating in a difficult case · the other event an hour late · workers drop out 30 min before. "The real question isn't 'is someone free?'. It's 'can we deliver this job without breaking something else?' That's why we built an AI Team Leader. Let me show you, live."</a:t>
-            </a:r>
-          </a:p>
-          <a:p>
-            <a:r>
-              <a:t>→ DEMO 1:15–3:30: FLUTURA narrates (pitch/SCRIPT.md), GENTI drives, ERZA + DEVLETE (Flutura's phone) on phones. Flutura ends: "AI plans. Code checks. A human approves. Plan in 16 s, all confirmed 8 s after approval, ~3 cents per plan."</a:t>
+              <a:t>FLUTURA (0:40–1:15) — EXAMPLE: Magic Events (permission). ~4 hours in a difficult case · the other event an hour late · workers drop out 30 min before. "The real question isn't 'is someone free?'. It's 'can we deliver this job without breaking something else?' That's why we built an AI Team Leader. Erza will show you, live."</a:t>
+            </a:r>
+          </a:p>
+          <a:p>
+            <a:r>
+              <a:t>→ DEMO 1:15–3:20: ERZA narrates (pitch/SCRIPT.md) · GENTI = panel · TRINGA = Erza's phone · FLUTURA = her own phone.</a:t>
             </a:r>
           </a:p>
         </p:txBody>
@@ -461,7 +461,7 @@
           <a:lstStyle/>
           <a:p>
             <a:r>
-              <a:t>FLUTURA (3:30–5:00) — Works for any team away from a desk: small business gets a team leader it couldn't hire; bigger companies get an assistant for their PMs, reports for every role. Honest market: Connecteam, Planner, Asana, Jira already help teams; we bring the whole handoff in one flow, in their chat, in Albanian. Next: proposed four-Saturday pilot with Magic Events. CLOSE: "Your leader keeps the client. We turn the 'yes' into a plan that holds, and follow it through to the end. Thank you."</a:t>
+              <a:t>DEVLETE (3:20–5:00) — "AI plans. Code checks. A human approves." Measured: plan in 16 s, all confirmed 8 s after approval, ~3 cents per plan. Any team away from a desk: small business gets a team leader it couldn't hire; bigger companies an assistant for their PMs. Honest market: Connecteam, Planner, Asana, Jira; we bring the whole handoff in one flow, in their chat, in Albanian. Next: proposed four-Saturday pilot with Magic Events. CLOSE: "Your leader keeps the client. We turn the 'yes' into a plan that holds, and follow it through to the end. Thank you."</a:t>
             </a:r>
           </a:p>
         </p:txBody>

</xml_diff>